<commit_message>
Add full real-life INR pricing ladder
</commit_message>
<xml_diff>
--- a/submission/LastNightAI_PitchDeck.pptx
+++ b/submission/LastNightAI_PitchDeck.pptx
@@ -2,16 +2,16 @@
 <file path=ppt/presentation.xml><?xml version="1.0" encoding="utf-8"?>
 <p:presentation xmlns:p="http://schemas.openxmlformats.org/presentationml/2006/main">
   <p:sldMasterIdLst>
-    <p:sldMasterId xmlns:r="http://schemas.openxmlformats.org/officeDocument/2006/relationships" id="2147483648" r:id="R296bf2d7ba334fb5"/>
+    <p:sldMasterId xmlns:r="http://schemas.openxmlformats.org/officeDocument/2006/relationships" id="2147483648" r:id="R961e6e5faceb448b"/>
   </p:sldMasterIdLst>
   <p:notesMasterIdLst>
-    <p:notesMasterId xmlns:r="http://schemas.openxmlformats.org/officeDocument/2006/relationships" r:id="Rc43669e0d7f043d2"/>
+    <p:notesMasterId xmlns:r="http://schemas.openxmlformats.org/officeDocument/2006/relationships" r:id="Rc17f5cf791f34ce3"/>
   </p:notesMasterIdLst>
   <p:sldIdLst>
-    <p:sldId xmlns:r="http://schemas.openxmlformats.org/officeDocument/2006/relationships" id="256" r:id="Rd4c65d3c0e2e4207"/>
-    <p:sldId xmlns:r="http://schemas.openxmlformats.org/officeDocument/2006/relationships" id="257" r:id="Rc865984179ab475f"/>
-    <p:sldId xmlns:r="http://schemas.openxmlformats.org/officeDocument/2006/relationships" id="258" r:id="R0b4abe48f5f64e7a"/>
-    <p:sldId xmlns:r="http://schemas.openxmlformats.org/officeDocument/2006/relationships" id="259" r:id="R7d0fd2255a69418f"/>
+    <p:sldId xmlns:r="http://schemas.openxmlformats.org/officeDocument/2006/relationships" id="256" r:id="R01244a4104d8452f"/>
+    <p:sldId xmlns:r="http://schemas.openxmlformats.org/officeDocument/2006/relationships" id="257" r:id="R8fa9f3d1bfad4fc5"/>
+    <p:sldId xmlns:r="http://schemas.openxmlformats.org/officeDocument/2006/relationships" id="258" r:id="R6e70346ffdb14d5f"/>
+    <p:sldId xmlns:r="http://schemas.openxmlformats.org/officeDocument/2006/relationships" id="259" r:id="R06ee0046ec8b4fe8"/>
   </p:sldIdLst>
   <p:sldSz cx="12192000" cy="6858000"/>
   <p:notesSz cx="6858000" cy="9144000"/>
@@ -756,7 +756,7 @@
   </p:cSld>
   <p:clrMap bg1="lt1" tx1="dk1" bg2="lt2" tx2="dk2" accent1="accent1" accent2="accent2" accent3="accent3" accent4="accent4" accent5="accent5" accent6="accent6" hlink="hlink" folHlink="folHlink"/>
   <p:sldLayoutIdLst>
-    <p:sldLayoutId xmlns:r="http://schemas.openxmlformats.org/officeDocument/2006/relationships" id="2147483649" r:id="R394c24fbf7cc42de"/>
+    <p:sldLayoutId xmlns:r="http://schemas.openxmlformats.org/officeDocument/2006/relationships" id="2147483649" r:id="Ree8870f28c364161"/>
   </p:sldLayoutIdLst>
   <p:txStyles>
     <p:titleStyle>
@@ -1055,7 +1055,7 @@
           <p:cNvPr id="1" name="">
             <a:extLst xmlns:a="http://schemas.openxmlformats.org/drawingml/2006/main">
               <a:ext uri="{FF2B5EF4-FFF2-40B4-BE49-F238E27FC236}">
-                <a16:creationId xmlns:a16="http://schemas.microsoft.com/office/drawing/2014/main" id="{40271890-3FEB-40D3-989A-C3E596934C85}"/>
+                <a16:creationId xmlns:a16="http://schemas.microsoft.com/office/drawing/2014/main" id="{E660EE1B-DBE5-41AD-9EC7-923B1C96A5DF}"/>
               </a:ext>
             </a:extLst>
           </p:cNvPr>
@@ -1090,7 +1090,7 @@
           <p:cNvPr id="2" name="">
             <a:extLst xmlns:a="http://schemas.openxmlformats.org/drawingml/2006/main">
               <a:ext uri="{FF2B5EF4-FFF2-40B4-BE49-F238E27FC236}">
-                <a16:creationId xmlns:a16="http://schemas.microsoft.com/office/drawing/2014/main" id="{DD881104-D644-46DF-BECD-E4C180C8C7F1}"/>
+                <a16:creationId xmlns:a16="http://schemas.microsoft.com/office/drawing/2014/main" id="{17E5763E-CFF4-4AF0-A662-7E4B307DE5A3}"/>
               </a:ext>
             </a:extLst>
           </p:cNvPr>
@@ -1125,7 +1125,7 @@
           <p:cNvPr id="3" name="">
             <a:extLst xmlns:a="http://schemas.openxmlformats.org/drawingml/2006/main">
               <a:ext uri="{FF2B5EF4-FFF2-40B4-BE49-F238E27FC236}">
-                <a16:creationId xmlns:a16="http://schemas.microsoft.com/office/drawing/2014/main" id="{6580F17A-0078-46CF-BC8D-917290BBC436}"/>
+                <a16:creationId xmlns:a16="http://schemas.microsoft.com/office/drawing/2014/main" id="{3735452B-9756-4B94-AF2C-2FB7B8418393}"/>
               </a:ext>
             </a:extLst>
           </p:cNvPr>
@@ -1160,7 +1160,7 @@
           <p:cNvPr id="4" name="">
             <a:extLst xmlns:a="http://schemas.openxmlformats.org/drawingml/2006/main">
               <a:ext uri="{FF2B5EF4-FFF2-40B4-BE49-F238E27FC236}">
-                <a16:creationId xmlns:a16="http://schemas.microsoft.com/office/drawing/2014/main" id="{7D08B366-6A7A-4424-AD58-D0C7991C601B}"/>
+                <a16:creationId xmlns:a16="http://schemas.microsoft.com/office/drawing/2014/main" id="{F5016795-9DB0-4CD1-BEF0-71237349C110}"/>
               </a:ext>
             </a:extLst>
           </p:cNvPr>
@@ -1224,7 +1224,7 @@
           <p:cNvPr id="5" name="">
             <a:extLst xmlns:a="http://schemas.openxmlformats.org/drawingml/2006/main">
               <a:ext uri="{FF2B5EF4-FFF2-40B4-BE49-F238E27FC236}">
-                <a16:creationId xmlns:a16="http://schemas.microsoft.com/office/drawing/2014/main" id="{146AD7FD-09E7-4BF1-97E4-B5185C4C9477}"/>
+                <a16:creationId xmlns:a16="http://schemas.microsoft.com/office/drawing/2014/main" id="{E724FFFC-7848-419A-8060-DCCCEEB91419}"/>
               </a:ext>
             </a:extLst>
           </p:cNvPr>
@@ -1288,7 +1288,7 @@
           <p:cNvPr id="6" name="">
             <a:extLst xmlns:a="http://schemas.openxmlformats.org/drawingml/2006/main">
               <a:ext uri="{FF2B5EF4-FFF2-40B4-BE49-F238E27FC236}">
-                <a16:creationId xmlns:a16="http://schemas.microsoft.com/office/drawing/2014/main" id="{69A088D7-DA25-44FA-8E5B-036003545122}"/>
+                <a16:creationId xmlns:a16="http://schemas.microsoft.com/office/drawing/2014/main" id="{3623A274-21C5-4DA6-B1D6-483914268C9A}"/>
               </a:ext>
             </a:extLst>
           </p:cNvPr>
@@ -1352,7 +1352,7 @@
           <p:cNvPr id="7" name="">
             <a:extLst xmlns:a="http://schemas.openxmlformats.org/drawingml/2006/main">
               <a:ext uri="{FF2B5EF4-FFF2-40B4-BE49-F238E27FC236}">
-                <a16:creationId xmlns:a16="http://schemas.microsoft.com/office/drawing/2014/main" id="{01A97EC3-D70F-47CF-BA28-D0D5EB6A1C2A}"/>
+                <a16:creationId xmlns:a16="http://schemas.microsoft.com/office/drawing/2014/main" id="{131E0842-066D-4143-A82E-9AEFF738D2AE}"/>
               </a:ext>
             </a:extLst>
           </p:cNvPr>
@@ -1416,7 +1416,7 @@
           <p:cNvPr id="8" name="">
             <a:extLst xmlns:a="http://schemas.openxmlformats.org/drawingml/2006/main">
               <a:ext uri="{FF2B5EF4-FFF2-40B4-BE49-F238E27FC236}">
-                <a16:creationId xmlns:a16="http://schemas.microsoft.com/office/drawing/2014/main" id="{A065B878-251A-430E-A0C2-72E7046C3086}"/>
+                <a16:creationId xmlns:a16="http://schemas.microsoft.com/office/drawing/2014/main" id="{FAB2AB2B-B446-4F19-8C2B-EEEA57FBFA4E}"/>
               </a:ext>
             </a:extLst>
           </p:cNvPr>
@@ -1480,7 +1480,7 @@
           <p:cNvPr id="9" name="">
             <a:extLst xmlns:a="http://schemas.openxmlformats.org/drawingml/2006/main">
               <a:ext uri="{FF2B5EF4-FFF2-40B4-BE49-F238E27FC236}">
-                <a16:creationId xmlns:a16="http://schemas.microsoft.com/office/drawing/2014/main" id="{FCC7DA21-A6A3-480B-B91F-9A68C54D5A17}"/>
+                <a16:creationId xmlns:a16="http://schemas.microsoft.com/office/drawing/2014/main" id="{00FD13A4-B198-43AB-8C70-1AFB381127A1}"/>
               </a:ext>
             </a:extLst>
           </p:cNvPr>
@@ -1544,7 +1544,7 @@
           <p:cNvPr id="10" name="">
             <a:extLst xmlns:a="http://schemas.openxmlformats.org/drawingml/2006/main">
               <a:ext uri="{FF2B5EF4-FFF2-40B4-BE49-F238E27FC236}">
-                <a16:creationId xmlns:a16="http://schemas.microsoft.com/office/drawing/2014/main" id="{9BF04AC9-5A67-46A7-BCAD-FF74BF26BEED}"/>
+                <a16:creationId xmlns:a16="http://schemas.microsoft.com/office/drawing/2014/main" id="{68E63103-4663-4B63-94AB-5CA1AFCD6E04}"/>
               </a:ext>
             </a:extLst>
           </p:cNvPr>
@@ -1577,7 +1577,7 @@
           <p:cNvPr id="11" name="">
             <a:extLst xmlns:a="http://schemas.openxmlformats.org/drawingml/2006/main">
               <a:ext uri="{FF2B5EF4-FFF2-40B4-BE49-F238E27FC236}">
-                <a16:creationId xmlns:a16="http://schemas.microsoft.com/office/drawing/2014/main" id="{2C60CDCB-B905-47A4-B597-F4AB0A5EF9E3}"/>
+                <a16:creationId xmlns:a16="http://schemas.microsoft.com/office/drawing/2014/main" id="{6302BE9F-34FC-46D1-9B45-C7C705DC1237}"/>
               </a:ext>
             </a:extLst>
           </p:cNvPr>
@@ -1612,7 +1612,7 @@
           <p:cNvPr id="12" name="">
             <a:extLst xmlns:a="http://schemas.openxmlformats.org/drawingml/2006/main">
               <a:ext uri="{FF2B5EF4-FFF2-40B4-BE49-F238E27FC236}">
-                <a16:creationId xmlns:a16="http://schemas.microsoft.com/office/drawing/2014/main" id="{1DA330E2-3786-451F-B46B-7CA6A7DEB084}"/>
+                <a16:creationId xmlns:a16="http://schemas.microsoft.com/office/drawing/2014/main" id="{FC3F1DC5-A96C-4D26-9EB5-D977A5204CFB}"/>
               </a:ext>
             </a:extLst>
           </p:cNvPr>
@@ -1676,7 +1676,7 @@
           <p:cNvPr id="13" name="">
             <a:extLst xmlns:a="http://schemas.openxmlformats.org/drawingml/2006/main">
               <a:ext uri="{FF2B5EF4-FFF2-40B4-BE49-F238E27FC236}">
-                <a16:creationId xmlns:a16="http://schemas.microsoft.com/office/drawing/2014/main" id="{762F1CA6-905C-4525-9C22-17E3EDA50BA8}"/>
+                <a16:creationId xmlns:a16="http://schemas.microsoft.com/office/drawing/2014/main" id="{233E7929-94A1-4F9F-A144-A35A607DAB15}"/>
               </a:ext>
             </a:extLst>
           </p:cNvPr>
@@ -1711,7 +1711,7 @@
           <p:cNvPr id="14" name="">
             <a:extLst xmlns:a="http://schemas.openxmlformats.org/drawingml/2006/main">
               <a:ext uri="{FF2B5EF4-FFF2-40B4-BE49-F238E27FC236}">
-                <a16:creationId xmlns:a16="http://schemas.microsoft.com/office/drawing/2014/main" id="{DA102A87-7239-4A2F-985C-E7F38BAD8C1C}"/>
+                <a16:creationId xmlns:a16="http://schemas.microsoft.com/office/drawing/2014/main" id="{A3E70337-603D-42C2-8153-3765C5D7A7BA}"/>
               </a:ext>
             </a:extLst>
           </p:cNvPr>
@@ -1775,7 +1775,7 @@
           <p:cNvPr id="15" name="">
             <a:extLst xmlns:a="http://schemas.openxmlformats.org/drawingml/2006/main">
               <a:ext uri="{FF2B5EF4-FFF2-40B4-BE49-F238E27FC236}">
-                <a16:creationId xmlns:a16="http://schemas.microsoft.com/office/drawing/2014/main" id="{9B0C980C-2B69-4402-8F83-CE294B3917BE}"/>
+                <a16:creationId xmlns:a16="http://schemas.microsoft.com/office/drawing/2014/main" id="{EF223395-AA66-4093-94C6-BDE16B62BAB6}"/>
               </a:ext>
             </a:extLst>
           </p:cNvPr>
@@ -1810,7 +1810,7 @@
           <p:cNvPr id="16" name="">
             <a:extLst xmlns:a="http://schemas.openxmlformats.org/drawingml/2006/main">
               <a:ext uri="{FF2B5EF4-FFF2-40B4-BE49-F238E27FC236}">
-                <a16:creationId xmlns:a16="http://schemas.microsoft.com/office/drawing/2014/main" id="{9EE66047-BC0E-4948-AB54-A7CCF39CBF60}"/>
+                <a16:creationId xmlns:a16="http://schemas.microsoft.com/office/drawing/2014/main" id="{5F794012-30EF-4D55-9479-C668BB11725E}"/>
               </a:ext>
             </a:extLst>
           </p:cNvPr>
@@ -1874,7 +1874,7 @@
           <p:cNvPr id="17" name="">
             <a:extLst xmlns:a="http://schemas.openxmlformats.org/drawingml/2006/main">
               <a:ext uri="{FF2B5EF4-FFF2-40B4-BE49-F238E27FC236}">
-                <a16:creationId xmlns:a16="http://schemas.microsoft.com/office/drawing/2014/main" id="{A09BD295-58A7-4071-84EC-014788E2CFBA}"/>
+                <a16:creationId xmlns:a16="http://schemas.microsoft.com/office/drawing/2014/main" id="{6A89E8EB-E8D6-459E-AE3C-A6068A073FA6}"/>
               </a:ext>
             </a:extLst>
           </p:cNvPr>
@@ -1907,7 +1907,7 @@
           <p:cNvPr id="18" name="">
             <a:extLst xmlns:a="http://schemas.openxmlformats.org/drawingml/2006/main">
               <a:ext uri="{FF2B5EF4-FFF2-40B4-BE49-F238E27FC236}">
-                <a16:creationId xmlns:a16="http://schemas.microsoft.com/office/drawing/2014/main" id="{E81D40C5-0CE9-4468-88ED-CBB9C9412734}"/>
+                <a16:creationId xmlns:a16="http://schemas.microsoft.com/office/drawing/2014/main" id="{899352F0-C521-425F-8521-388B85AAAA01}"/>
               </a:ext>
             </a:extLst>
           </p:cNvPr>
@@ -1971,7 +1971,7 @@
           <p:cNvPr id="19" name="">
             <a:extLst xmlns:a="http://schemas.openxmlformats.org/drawingml/2006/main">
               <a:ext uri="{FF2B5EF4-FFF2-40B4-BE49-F238E27FC236}">
-                <a16:creationId xmlns:a16="http://schemas.microsoft.com/office/drawing/2014/main" id="{5764B864-FB48-4593-A8E0-0133B23D10ED}"/>
+                <a16:creationId xmlns:a16="http://schemas.microsoft.com/office/drawing/2014/main" id="{FD70FF36-4B3D-4E52-8106-337DD8A07BB4}"/>
               </a:ext>
             </a:extLst>
           </p:cNvPr>
@@ -2004,7 +2004,7 @@
           <p:cNvPr id="20" name="">
             <a:extLst xmlns:a="http://schemas.openxmlformats.org/drawingml/2006/main">
               <a:ext uri="{FF2B5EF4-FFF2-40B4-BE49-F238E27FC236}">
-                <a16:creationId xmlns:a16="http://schemas.microsoft.com/office/drawing/2014/main" id="{BDCC5F4F-082D-45F9-8EB3-A0877E63787E}"/>
+                <a16:creationId xmlns:a16="http://schemas.microsoft.com/office/drawing/2014/main" id="{C27D56AD-40BF-44B1-A359-31A78568F8FE}"/>
               </a:ext>
             </a:extLst>
           </p:cNvPr>
@@ -2039,7 +2039,7 @@
           <p:cNvPr id="21" name="">
             <a:extLst xmlns:a="http://schemas.openxmlformats.org/drawingml/2006/main">
               <a:ext uri="{FF2B5EF4-FFF2-40B4-BE49-F238E27FC236}">
-                <a16:creationId xmlns:a16="http://schemas.microsoft.com/office/drawing/2014/main" id="{89A892C1-36E9-4406-8FFE-8DA6FBC6B5CC}"/>
+                <a16:creationId xmlns:a16="http://schemas.microsoft.com/office/drawing/2014/main" id="{BBDEAC0D-BE8F-461C-A7A5-E2E144422C13}"/>
               </a:ext>
             </a:extLst>
           </p:cNvPr>
@@ -2074,7 +2074,7 @@
           <p:cNvPr id="22" name="">
             <a:extLst xmlns:a="http://schemas.openxmlformats.org/drawingml/2006/main">
               <a:ext uri="{FF2B5EF4-FFF2-40B4-BE49-F238E27FC236}">
-                <a16:creationId xmlns:a16="http://schemas.microsoft.com/office/drawing/2014/main" id="{E2C61180-4324-42FE-AC22-87B10D3C1714}"/>
+                <a16:creationId xmlns:a16="http://schemas.microsoft.com/office/drawing/2014/main" id="{51EC710B-2AD4-4B83-AFDE-C6178499FE98}"/>
               </a:ext>
             </a:extLst>
           </p:cNvPr>
@@ -2109,7 +2109,7 @@
           <p:cNvPr id="23" name="">
             <a:extLst xmlns:a="http://schemas.openxmlformats.org/drawingml/2006/main">
               <a:ext uri="{FF2B5EF4-FFF2-40B4-BE49-F238E27FC236}">
-                <a16:creationId xmlns:a16="http://schemas.microsoft.com/office/drawing/2014/main" id="{DC1BB9E9-B67F-4C00-9C91-FEF4B1D29509}"/>
+                <a16:creationId xmlns:a16="http://schemas.microsoft.com/office/drawing/2014/main" id="{39388F6D-D442-4347-9859-E7916F1897B3}"/>
               </a:ext>
             </a:extLst>
           </p:cNvPr>
@@ -2173,7 +2173,7 @@
           <p:cNvPr id="24" name="">
             <a:extLst xmlns:a="http://schemas.openxmlformats.org/drawingml/2006/main">
               <a:ext uri="{FF2B5EF4-FFF2-40B4-BE49-F238E27FC236}">
-                <a16:creationId xmlns:a16="http://schemas.microsoft.com/office/drawing/2014/main" id="{1A4116BD-C5A4-4270-91A0-9010977D39E0}"/>
+                <a16:creationId xmlns:a16="http://schemas.microsoft.com/office/drawing/2014/main" id="{6508B1A2-BDA6-404A-AEDA-02BC0221585E}"/>
               </a:ext>
             </a:extLst>
           </p:cNvPr>
@@ -2237,7 +2237,7 @@
           <p:cNvPr id="25" name="">
             <a:extLst xmlns:a="http://schemas.openxmlformats.org/drawingml/2006/main">
               <a:ext uri="{FF2B5EF4-FFF2-40B4-BE49-F238E27FC236}">
-                <a16:creationId xmlns:a16="http://schemas.microsoft.com/office/drawing/2014/main" id="{33B2ED3A-A1B7-4928-8789-6C87054A3026}"/>
+                <a16:creationId xmlns:a16="http://schemas.microsoft.com/office/drawing/2014/main" id="{0DAC3D30-74F0-40A1-90B7-7DEE7DD6B967}"/>
               </a:ext>
             </a:extLst>
           </p:cNvPr>
@@ -2301,7 +2301,7 @@
           <p:cNvPr id="26" name="">
             <a:extLst xmlns:a="http://schemas.openxmlformats.org/drawingml/2006/main">
               <a:ext uri="{FF2B5EF4-FFF2-40B4-BE49-F238E27FC236}">
-                <a16:creationId xmlns:a16="http://schemas.microsoft.com/office/drawing/2014/main" id="{BBDAF7F1-64E9-4C31-9160-3D1D1DA1FF3A}"/>
+                <a16:creationId xmlns:a16="http://schemas.microsoft.com/office/drawing/2014/main" id="{AD8288D2-8A81-460E-B3D8-F11C30A4DBDF}"/>
               </a:ext>
             </a:extLst>
           </p:cNvPr>
@@ -2363,7 +2363,7 @@
     </p:spTree>
     <p:extLst>
       <p:ext uri="{BB962C8B-B14F-4D97-AF65-F5344CB8AC3E}">
-        <p14:creationId xmlns:p14="http://schemas.microsoft.com/office/powerpoint/2010/main" val="1718840462"/>
+        <p14:creationId xmlns:p14="http://schemas.microsoft.com/office/powerpoint/2010/main" val="1814183202"/>
       </p:ext>
     </p:extLst>
   </p:cSld>
@@ -2387,7 +2387,7 @@
           <p:cNvPr id="1" name="">
             <a:extLst xmlns:a="http://schemas.openxmlformats.org/drawingml/2006/main">
               <a:ext uri="{FF2B5EF4-FFF2-40B4-BE49-F238E27FC236}">
-                <a16:creationId xmlns:a16="http://schemas.microsoft.com/office/drawing/2014/main" id="{D6D09C69-E361-40B7-994A-AECD388F6225}"/>
+                <a16:creationId xmlns:a16="http://schemas.microsoft.com/office/drawing/2014/main" id="{3B8C8F14-D4FF-4199-8CC3-5E7478A987A5}"/>
               </a:ext>
             </a:extLst>
           </p:cNvPr>
@@ -2422,7 +2422,7 @@
           <p:cNvPr id="2" name="">
             <a:extLst xmlns:a="http://schemas.openxmlformats.org/drawingml/2006/main">
               <a:ext uri="{FF2B5EF4-FFF2-40B4-BE49-F238E27FC236}">
-                <a16:creationId xmlns:a16="http://schemas.microsoft.com/office/drawing/2014/main" id="{0D9A2228-8EB0-4EA1-A00C-AACF33E01964}"/>
+                <a16:creationId xmlns:a16="http://schemas.microsoft.com/office/drawing/2014/main" id="{CE4B35C1-2DC8-477E-9C1A-43171F4F95AC}"/>
               </a:ext>
             </a:extLst>
           </p:cNvPr>
@@ -2457,7 +2457,7 @@
           <p:cNvPr id="3" name="">
             <a:extLst xmlns:a="http://schemas.openxmlformats.org/drawingml/2006/main">
               <a:ext uri="{FF2B5EF4-FFF2-40B4-BE49-F238E27FC236}">
-                <a16:creationId xmlns:a16="http://schemas.microsoft.com/office/drawing/2014/main" id="{37869A0E-C53C-48E2-A9E3-BD76824756F0}"/>
+                <a16:creationId xmlns:a16="http://schemas.microsoft.com/office/drawing/2014/main" id="{3936A3E3-A584-49EA-ACC2-83E9C9F37A58}"/>
               </a:ext>
             </a:extLst>
           </p:cNvPr>
@@ -2492,7 +2492,7 @@
           <p:cNvPr id="4" name="">
             <a:extLst xmlns:a="http://schemas.openxmlformats.org/drawingml/2006/main">
               <a:ext uri="{FF2B5EF4-FFF2-40B4-BE49-F238E27FC236}">
-                <a16:creationId xmlns:a16="http://schemas.microsoft.com/office/drawing/2014/main" id="{61A74D75-2508-48D2-B06C-DF47D9EEA548}"/>
+                <a16:creationId xmlns:a16="http://schemas.microsoft.com/office/drawing/2014/main" id="{1E6C70C2-36B6-4AC5-9A38-AC5D038969F0}"/>
               </a:ext>
             </a:extLst>
           </p:cNvPr>
@@ -2556,7 +2556,7 @@
           <p:cNvPr id="5" name="">
             <a:extLst xmlns:a="http://schemas.openxmlformats.org/drawingml/2006/main">
               <a:ext uri="{FF2B5EF4-FFF2-40B4-BE49-F238E27FC236}">
-                <a16:creationId xmlns:a16="http://schemas.microsoft.com/office/drawing/2014/main" id="{FED12A44-B8CC-4F4D-95D3-17227C916D90}"/>
+                <a16:creationId xmlns:a16="http://schemas.microsoft.com/office/drawing/2014/main" id="{9A59BBC6-4DF5-4170-8D45-C60792E5DF26}"/>
               </a:ext>
             </a:extLst>
           </p:cNvPr>
@@ -2620,7 +2620,7 @@
           <p:cNvPr id="6" name="">
             <a:extLst xmlns:a="http://schemas.openxmlformats.org/drawingml/2006/main">
               <a:ext uri="{FF2B5EF4-FFF2-40B4-BE49-F238E27FC236}">
-                <a16:creationId xmlns:a16="http://schemas.microsoft.com/office/drawing/2014/main" id="{54B43E79-36B0-48E6-AF0F-79E3820F0680}"/>
+                <a16:creationId xmlns:a16="http://schemas.microsoft.com/office/drawing/2014/main" id="{1F5114F9-68EC-49D7-AB81-002D5811902D}"/>
               </a:ext>
             </a:extLst>
           </p:cNvPr>
@@ -2684,7 +2684,7 @@
           <p:cNvPr id="7" name="">
             <a:extLst xmlns:a="http://schemas.openxmlformats.org/drawingml/2006/main">
               <a:ext uri="{FF2B5EF4-FFF2-40B4-BE49-F238E27FC236}">
-                <a16:creationId xmlns:a16="http://schemas.microsoft.com/office/drawing/2014/main" id="{80D282DC-B46F-4517-984C-0F38E5F30CCA}"/>
+                <a16:creationId xmlns:a16="http://schemas.microsoft.com/office/drawing/2014/main" id="{0DDFAEE5-D07D-4ABD-BEB8-A150BAA632AB}"/>
               </a:ext>
             </a:extLst>
           </p:cNvPr>
@@ -2748,7 +2748,7 @@
           <p:cNvPr id="8" name="">
             <a:extLst xmlns:a="http://schemas.openxmlformats.org/drawingml/2006/main">
               <a:ext uri="{FF2B5EF4-FFF2-40B4-BE49-F238E27FC236}">
-                <a16:creationId xmlns:a16="http://schemas.microsoft.com/office/drawing/2014/main" id="{4133D19B-C40E-4657-A32D-36EFFA7EFD3C}"/>
+                <a16:creationId xmlns:a16="http://schemas.microsoft.com/office/drawing/2014/main" id="{ED51AED0-21D5-4CC5-8840-EBF2EB03ABFA}"/>
               </a:ext>
             </a:extLst>
           </p:cNvPr>
@@ -2812,7 +2812,7 @@
           <p:cNvPr id="9" name="">
             <a:extLst xmlns:a="http://schemas.openxmlformats.org/drawingml/2006/main">
               <a:ext uri="{FF2B5EF4-FFF2-40B4-BE49-F238E27FC236}">
-                <a16:creationId xmlns:a16="http://schemas.microsoft.com/office/drawing/2014/main" id="{3639C3F9-CF57-4D23-942B-56F758860C98}"/>
+                <a16:creationId xmlns:a16="http://schemas.microsoft.com/office/drawing/2014/main" id="{CC5644C9-BF30-48F1-B241-5F03DF5B3996}"/>
               </a:ext>
             </a:extLst>
           </p:cNvPr>
@@ -2876,7 +2876,7 @@
           <p:cNvPr id="10" name="">
             <a:extLst xmlns:a="http://schemas.openxmlformats.org/drawingml/2006/main">
               <a:ext uri="{FF2B5EF4-FFF2-40B4-BE49-F238E27FC236}">
-                <a16:creationId xmlns:a16="http://schemas.microsoft.com/office/drawing/2014/main" id="{C3837180-B30C-4053-8579-630C8C8DF218}"/>
+                <a16:creationId xmlns:a16="http://schemas.microsoft.com/office/drawing/2014/main" id="{C5AEA23E-0B36-4472-BB0A-DD3F3E9FF30F}"/>
               </a:ext>
             </a:extLst>
           </p:cNvPr>
@@ -2909,7 +2909,7 @@
           <p:cNvPr id="11" name="">
             <a:extLst xmlns:a="http://schemas.openxmlformats.org/drawingml/2006/main">
               <a:ext uri="{FF2B5EF4-FFF2-40B4-BE49-F238E27FC236}">
-                <a16:creationId xmlns:a16="http://schemas.microsoft.com/office/drawing/2014/main" id="{B5F23374-2EA1-4CDB-B314-F3192BB20755}"/>
+                <a16:creationId xmlns:a16="http://schemas.microsoft.com/office/drawing/2014/main" id="{AAB0A6D4-0E1D-4291-B4BF-0B33FF4E2642}"/>
               </a:ext>
             </a:extLst>
           </p:cNvPr>
@@ -2973,7 +2973,7 @@
           <p:cNvPr id="12" name="">
             <a:extLst xmlns:a="http://schemas.openxmlformats.org/drawingml/2006/main">
               <a:ext uri="{FF2B5EF4-FFF2-40B4-BE49-F238E27FC236}">
-                <a16:creationId xmlns:a16="http://schemas.microsoft.com/office/drawing/2014/main" id="{8B7A3237-0EC9-4222-97F3-8BB84AB9397B}"/>
+                <a16:creationId xmlns:a16="http://schemas.microsoft.com/office/drawing/2014/main" id="{9CAB33CB-E948-4BFE-91E0-A7A43FF89B64}"/>
               </a:ext>
             </a:extLst>
           </p:cNvPr>
@@ -3037,7 +3037,7 @@
           <p:cNvPr id="13" name="">
             <a:extLst xmlns:a="http://schemas.openxmlformats.org/drawingml/2006/main">
               <a:ext uri="{FF2B5EF4-FFF2-40B4-BE49-F238E27FC236}">
-                <a16:creationId xmlns:a16="http://schemas.microsoft.com/office/drawing/2014/main" id="{261C5665-566F-4034-839C-194772DAEB0E}"/>
+                <a16:creationId xmlns:a16="http://schemas.microsoft.com/office/drawing/2014/main" id="{691135BD-28ED-43B9-ABA0-490A53965134}"/>
               </a:ext>
             </a:extLst>
           </p:cNvPr>
@@ -3101,7 +3101,7 @@
           <p:cNvPr id="14" name="">
             <a:extLst xmlns:a="http://schemas.openxmlformats.org/drawingml/2006/main">
               <a:ext uri="{FF2B5EF4-FFF2-40B4-BE49-F238E27FC236}">
-                <a16:creationId xmlns:a16="http://schemas.microsoft.com/office/drawing/2014/main" id="{87CD58E0-406B-43D1-B437-7166CF765C26}"/>
+                <a16:creationId xmlns:a16="http://schemas.microsoft.com/office/drawing/2014/main" id="{F8B44E54-0B39-4884-9257-A731D03F1A04}"/>
               </a:ext>
             </a:extLst>
           </p:cNvPr>
@@ -3136,7 +3136,7 @@
           <p:cNvPr id="15" name="">
             <a:extLst xmlns:a="http://schemas.openxmlformats.org/drawingml/2006/main">
               <a:ext uri="{FF2B5EF4-FFF2-40B4-BE49-F238E27FC236}">
-                <a16:creationId xmlns:a16="http://schemas.microsoft.com/office/drawing/2014/main" id="{620495FA-0948-4E1A-BA81-7667F39A9553}"/>
+                <a16:creationId xmlns:a16="http://schemas.microsoft.com/office/drawing/2014/main" id="{53E837BC-E5F2-4839-9E06-03096134D10E}"/>
               </a:ext>
             </a:extLst>
           </p:cNvPr>
@@ -3171,7 +3171,7 @@
           <p:cNvPr id="16" name="">
             <a:extLst xmlns:a="http://schemas.openxmlformats.org/drawingml/2006/main">
               <a:ext uri="{FF2B5EF4-FFF2-40B4-BE49-F238E27FC236}">
-                <a16:creationId xmlns:a16="http://schemas.microsoft.com/office/drawing/2014/main" id="{91547167-24F2-4B32-8689-DA1ADF0B1D42}"/>
+                <a16:creationId xmlns:a16="http://schemas.microsoft.com/office/drawing/2014/main" id="{583BB57B-37FA-4CB7-8AED-DA83EE567FC1}"/>
               </a:ext>
             </a:extLst>
           </p:cNvPr>
@@ -3204,7 +3204,7 @@
           <p:cNvPr id="17" name="">
             <a:extLst xmlns:a="http://schemas.openxmlformats.org/drawingml/2006/main">
               <a:ext uri="{FF2B5EF4-FFF2-40B4-BE49-F238E27FC236}">
-                <a16:creationId xmlns:a16="http://schemas.microsoft.com/office/drawing/2014/main" id="{1CB570A8-8646-4C04-9C45-B9BA3F357857}"/>
+                <a16:creationId xmlns:a16="http://schemas.microsoft.com/office/drawing/2014/main" id="{E49CF70E-D754-4F73-A364-4450FE3B48A5}"/>
               </a:ext>
             </a:extLst>
           </p:cNvPr>
@@ -3268,7 +3268,7 @@
           <p:cNvPr id="18" name="">
             <a:extLst xmlns:a="http://schemas.openxmlformats.org/drawingml/2006/main">
               <a:ext uri="{FF2B5EF4-FFF2-40B4-BE49-F238E27FC236}">
-                <a16:creationId xmlns:a16="http://schemas.microsoft.com/office/drawing/2014/main" id="{7FFC33F6-6D17-4F3B-B15A-38882AEF2C1C}"/>
+                <a16:creationId xmlns:a16="http://schemas.microsoft.com/office/drawing/2014/main" id="{FD3621FA-0841-42CE-98E6-3AF2BF94F2AC}"/>
               </a:ext>
             </a:extLst>
           </p:cNvPr>
@@ -3332,7 +3332,7 @@
           <p:cNvPr id="19" name="">
             <a:extLst xmlns:a="http://schemas.openxmlformats.org/drawingml/2006/main">
               <a:ext uri="{FF2B5EF4-FFF2-40B4-BE49-F238E27FC236}">
-                <a16:creationId xmlns:a16="http://schemas.microsoft.com/office/drawing/2014/main" id="{567FD4CA-9AC8-431A-8C97-C4FA5036B901}"/>
+                <a16:creationId xmlns:a16="http://schemas.microsoft.com/office/drawing/2014/main" id="{E6A314C1-9683-43A4-8504-E6220A05881A}"/>
               </a:ext>
             </a:extLst>
           </p:cNvPr>
@@ -3396,7 +3396,7 @@
           <p:cNvPr id="20" name="">
             <a:extLst xmlns:a="http://schemas.openxmlformats.org/drawingml/2006/main">
               <a:ext uri="{FF2B5EF4-FFF2-40B4-BE49-F238E27FC236}">
-                <a16:creationId xmlns:a16="http://schemas.microsoft.com/office/drawing/2014/main" id="{B7EBC44B-0D44-4843-AEEC-4E9EF92286A2}"/>
+                <a16:creationId xmlns:a16="http://schemas.microsoft.com/office/drawing/2014/main" id="{D3A8B559-D07B-468A-BA6C-514920B07971}"/>
               </a:ext>
             </a:extLst>
           </p:cNvPr>
@@ -3431,7 +3431,7 @@
           <p:cNvPr id="21" name="">
             <a:extLst xmlns:a="http://schemas.openxmlformats.org/drawingml/2006/main">
               <a:ext uri="{FF2B5EF4-FFF2-40B4-BE49-F238E27FC236}">
-                <a16:creationId xmlns:a16="http://schemas.microsoft.com/office/drawing/2014/main" id="{AE4FDB20-6EF7-4EDF-8356-098ACD8C9D03}"/>
+                <a16:creationId xmlns:a16="http://schemas.microsoft.com/office/drawing/2014/main" id="{61F250FF-F9AA-4578-9976-F30D56B1E8E4}"/>
               </a:ext>
             </a:extLst>
           </p:cNvPr>
@@ -3466,7 +3466,7 @@
           <p:cNvPr id="22" name="">
             <a:extLst xmlns:a="http://schemas.openxmlformats.org/drawingml/2006/main">
               <a:ext uri="{FF2B5EF4-FFF2-40B4-BE49-F238E27FC236}">
-                <a16:creationId xmlns:a16="http://schemas.microsoft.com/office/drawing/2014/main" id="{2C136FED-5EBD-44FF-99F0-BB4538363377}"/>
+                <a16:creationId xmlns:a16="http://schemas.microsoft.com/office/drawing/2014/main" id="{9B6E7BE1-9199-4390-8223-F8EA4F31C4A8}"/>
               </a:ext>
             </a:extLst>
           </p:cNvPr>
@@ -3499,7 +3499,7 @@
           <p:cNvPr id="23" name="">
             <a:extLst xmlns:a="http://schemas.openxmlformats.org/drawingml/2006/main">
               <a:ext uri="{FF2B5EF4-FFF2-40B4-BE49-F238E27FC236}">
-                <a16:creationId xmlns:a16="http://schemas.microsoft.com/office/drawing/2014/main" id="{266D625E-B4CE-4DA6-86A6-24838414780C}"/>
+                <a16:creationId xmlns:a16="http://schemas.microsoft.com/office/drawing/2014/main" id="{18569FDB-5884-45BE-BEB3-E61FF2F1C25A}"/>
               </a:ext>
             </a:extLst>
           </p:cNvPr>
@@ -3563,7 +3563,7 @@
           <p:cNvPr id="24" name="">
             <a:extLst xmlns:a="http://schemas.openxmlformats.org/drawingml/2006/main">
               <a:ext uri="{FF2B5EF4-FFF2-40B4-BE49-F238E27FC236}">
-                <a16:creationId xmlns:a16="http://schemas.microsoft.com/office/drawing/2014/main" id="{400EE444-3A2B-4912-AF9F-7A50C423455B}"/>
+                <a16:creationId xmlns:a16="http://schemas.microsoft.com/office/drawing/2014/main" id="{7328D7EA-63DF-4560-991D-E637B400F0B6}"/>
               </a:ext>
             </a:extLst>
           </p:cNvPr>
@@ -3627,7 +3627,7 @@
           <p:cNvPr id="25" name="">
             <a:extLst xmlns:a="http://schemas.openxmlformats.org/drawingml/2006/main">
               <a:ext uri="{FF2B5EF4-FFF2-40B4-BE49-F238E27FC236}">
-                <a16:creationId xmlns:a16="http://schemas.microsoft.com/office/drawing/2014/main" id="{D6EADC35-4042-4899-A0D4-A6C7FB7420A3}"/>
+                <a16:creationId xmlns:a16="http://schemas.microsoft.com/office/drawing/2014/main" id="{477354D5-49F8-42BA-98D2-CAC028C70352}"/>
               </a:ext>
             </a:extLst>
           </p:cNvPr>
@@ -3691,7 +3691,7 @@
           <p:cNvPr id="26" name="">
             <a:extLst xmlns:a="http://schemas.openxmlformats.org/drawingml/2006/main">
               <a:ext uri="{FF2B5EF4-FFF2-40B4-BE49-F238E27FC236}">
-                <a16:creationId xmlns:a16="http://schemas.microsoft.com/office/drawing/2014/main" id="{668197B3-196B-4E44-85AA-6058ACC326BB}"/>
+                <a16:creationId xmlns:a16="http://schemas.microsoft.com/office/drawing/2014/main" id="{4E51D8E7-FCA5-4F78-8218-1EB077590F68}"/>
               </a:ext>
             </a:extLst>
           </p:cNvPr>
@@ -3726,7 +3726,7 @@
           <p:cNvPr id="27" name="">
             <a:extLst xmlns:a="http://schemas.openxmlformats.org/drawingml/2006/main">
               <a:ext uri="{FF2B5EF4-FFF2-40B4-BE49-F238E27FC236}">
-                <a16:creationId xmlns:a16="http://schemas.microsoft.com/office/drawing/2014/main" id="{657A5EE2-42CC-478D-8557-519F0031CDB2}"/>
+                <a16:creationId xmlns:a16="http://schemas.microsoft.com/office/drawing/2014/main" id="{228A656D-B722-4A07-85C7-64D2AA2E4B3D}"/>
               </a:ext>
             </a:extLst>
           </p:cNvPr>
@@ -3761,7 +3761,7 @@
           <p:cNvPr id="28" name="">
             <a:extLst xmlns:a="http://schemas.openxmlformats.org/drawingml/2006/main">
               <a:ext uri="{FF2B5EF4-FFF2-40B4-BE49-F238E27FC236}">
-                <a16:creationId xmlns:a16="http://schemas.microsoft.com/office/drawing/2014/main" id="{CF6D7E33-30FC-443E-8195-3494B9164CEF}"/>
+                <a16:creationId xmlns:a16="http://schemas.microsoft.com/office/drawing/2014/main" id="{CB4078E8-CC05-4AB1-A736-2EDA6292E660}"/>
               </a:ext>
             </a:extLst>
           </p:cNvPr>
@@ -3794,7 +3794,7 @@
           <p:cNvPr id="29" name="">
             <a:extLst xmlns:a="http://schemas.openxmlformats.org/drawingml/2006/main">
               <a:ext uri="{FF2B5EF4-FFF2-40B4-BE49-F238E27FC236}">
-                <a16:creationId xmlns:a16="http://schemas.microsoft.com/office/drawing/2014/main" id="{A59F3D76-9635-4C6D-9289-53ADC3697831}"/>
+                <a16:creationId xmlns:a16="http://schemas.microsoft.com/office/drawing/2014/main" id="{75788B4D-2BA6-4BF3-B871-D36DAE7C299A}"/>
               </a:ext>
             </a:extLst>
           </p:cNvPr>
@@ -3858,7 +3858,7 @@
           <p:cNvPr id="30" name="">
             <a:extLst xmlns:a="http://schemas.openxmlformats.org/drawingml/2006/main">
               <a:ext uri="{FF2B5EF4-FFF2-40B4-BE49-F238E27FC236}">
-                <a16:creationId xmlns:a16="http://schemas.microsoft.com/office/drawing/2014/main" id="{452C88E3-D877-4D3A-822D-2D2DAA32E918}"/>
+                <a16:creationId xmlns:a16="http://schemas.microsoft.com/office/drawing/2014/main" id="{277E1628-895C-41C4-B8C2-714075A9A938}"/>
               </a:ext>
             </a:extLst>
           </p:cNvPr>
@@ -3922,7 +3922,7 @@
           <p:cNvPr id="31" name="">
             <a:extLst xmlns:a="http://schemas.openxmlformats.org/drawingml/2006/main">
               <a:ext uri="{FF2B5EF4-FFF2-40B4-BE49-F238E27FC236}">
-                <a16:creationId xmlns:a16="http://schemas.microsoft.com/office/drawing/2014/main" id="{E225F15E-5DAA-4CF5-B5B0-E420B6CFCBFC}"/>
+                <a16:creationId xmlns:a16="http://schemas.microsoft.com/office/drawing/2014/main" id="{D2CE4F8B-8432-4934-91BC-1430D3A1751E}"/>
               </a:ext>
             </a:extLst>
           </p:cNvPr>
@@ -3986,7 +3986,7 @@
           <p:cNvPr id="32" name="">
             <a:extLst xmlns:a="http://schemas.openxmlformats.org/drawingml/2006/main">
               <a:ext uri="{FF2B5EF4-FFF2-40B4-BE49-F238E27FC236}">
-                <a16:creationId xmlns:a16="http://schemas.microsoft.com/office/drawing/2014/main" id="{A5E0DF07-CF7B-4CE2-A6B5-739E62508724}"/>
+                <a16:creationId xmlns:a16="http://schemas.microsoft.com/office/drawing/2014/main" id="{36A27B9E-C7CA-42CD-86D8-C852A3B2B4BB}"/>
               </a:ext>
             </a:extLst>
           </p:cNvPr>
@@ -4019,7 +4019,7 @@
           <p:cNvPr id="33" name="">
             <a:extLst xmlns:a="http://schemas.openxmlformats.org/drawingml/2006/main">
               <a:ext uri="{FF2B5EF4-FFF2-40B4-BE49-F238E27FC236}">
-                <a16:creationId xmlns:a16="http://schemas.microsoft.com/office/drawing/2014/main" id="{CE8FA1DD-7503-4296-9701-B1DCD5238F68}"/>
+                <a16:creationId xmlns:a16="http://schemas.microsoft.com/office/drawing/2014/main" id="{663818EB-EDA5-4722-99AE-B132FD20143F}"/>
               </a:ext>
             </a:extLst>
           </p:cNvPr>
@@ -4083,7 +4083,7 @@
           <p:cNvPr id="34" name="">
             <a:extLst xmlns:a="http://schemas.openxmlformats.org/drawingml/2006/main">
               <a:ext uri="{FF2B5EF4-FFF2-40B4-BE49-F238E27FC236}">
-                <a16:creationId xmlns:a16="http://schemas.microsoft.com/office/drawing/2014/main" id="{7492CD6B-744F-432F-BD71-EFB460ECABBD}"/>
+                <a16:creationId xmlns:a16="http://schemas.microsoft.com/office/drawing/2014/main" id="{1F9A012C-340C-45B3-B098-8B1931B93AB1}"/>
               </a:ext>
             </a:extLst>
           </p:cNvPr>
@@ -4116,7 +4116,7 @@
           <p:cNvPr id="35" name="">
             <a:extLst xmlns:a="http://schemas.openxmlformats.org/drawingml/2006/main">
               <a:ext uri="{FF2B5EF4-FFF2-40B4-BE49-F238E27FC236}">
-                <a16:creationId xmlns:a16="http://schemas.microsoft.com/office/drawing/2014/main" id="{2F452E13-7D93-41AE-8E9B-AE78A0FB647A}"/>
+                <a16:creationId xmlns:a16="http://schemas.microsoft.com/office/drawing/2014/main" id="{60D20510-B7AD-472D-B44D-473517BF7F4A}"/>
               </a:ext>
             </a:extLst>
           </p:cNvPr>
@@ -4180,7 +4180,7 @@
           <p:cNvPr id="36" name="">
             <a:extLst xmlns:a="http://schemas.openxmlformats.org/drawingml/2006/main">
               <a:ext uri="{FF2B5EF4-FFF2-40B4-BE49-F238E27FC236}">
-                <a16:creationId xmlns:a16="http://schemas.microsoft.com/office/drawing/2014/main" id="{27B4216A-1AA8-4EA1-BB0F-6E524DFDB179}"/>
+                <a16:creationId xmlns:a16="http://schemas.microsoft.com/office/drawing/2014/main" id="{DA2DFD63-4BDF-4DE7-B580-29F85633C7F3}"/>
               </a:ext>
             </a:extLst>
           </p:cNvPr>
@@ -4213,7 +4213,7 @@
           <p:cNvPr id="37" name="">
             <a:extLst xmlns:a="http://schemas.openxmlformats.org/drawingml/2006/main">
               <a:ext uri="{FF2B5EF4-FFF2-40B4-BE49-F238E27FC236}">
-                <a16:creationId xmlns:a16="http://schemas.microsoft.com/office/drawing/2014/main" id="{5E634460-E968-411B-9E92-7552416A5C4A}"/>
+                <a16:creationId xmlns:a16="http://schemas.microsoft.com/office/drawing/2014/main" id="{94851B4B-2EAD-436D-B078-307C17F35FCF}"/>
               </a:ext>
             </a:extLst>
           </p:cNvPr>
@@ -4277,7 +4277,7 @@
           <p:cNvPr id="38" name="">
             <a:extLst xmlns:a="http://schemas.openxmlformats.org/drawingml/2006/main">
               <a:ext uri="{FF2B5EF4-FFF2-40B4-BE49-F238E27FC236}">
-                <a16:creationId xmlns:a16="http://schemas.microsoft.com/office/drawing/2014/main" id="{401B7E7B-D90C-4291-99D6-8C876F8E3923}"/>
+                <a16:creationId xmlns:a16="http://schemas.microsoft.com/office/drawing/2014/main" id="{3F6A84AE-C621-4486-8364-0205BC4AB9DE}"/>
               </a:ext>
             </a:extLst>
           </p:cNvPr>
@@ -4310,7 +4310,7 @@
           <p:cNvPr id="39" name="">
             <a:extLst xmlns:a="http://schemas.openxmlformats.org/drawingml/2006/main">
               <a:ext uri="{FF2B5EF4-FFF2-40B4-BE49-F238E27FC236}">
-                <a16:creationId xmlns:a16="http://schemas.microsoft.com/office/drawing/2014/main" id="{7E08C41C-B958-4EBC-9912-DD3CD0A72C25}"/>
+                <a16:creationId xmlns:a16="http://schemas.microsoft.com/office/drawing/2014/main" id="{09EAB1AC-C1EA-4449-9837-BEA40F261C4E}"/>
               </a:ext>
             </a:extLst>
           </p:cNvPr>
@@ -4374,7 +4374,7 @@
           <p:cNvPr id="40" name="">
             <a:extLst xmlns:a="http://schemas.openxmlformats.org/drawingml/2006/main">
               <a:ext uri="{FF2B5EF4-FFF2-40B4-BE49-F238E27FC236}">
-                <a16:creationId xmlns:a16="http://schemas.microsoft.com/office/drawing/2014/main" id="{22941C5F-2310-4FE0-9ADD-1867AD885409}"/>
+                <a16:creationId xmlns:a16="http://schemas.microsoft.com/office/drawing/2014/main" id="{C818A294-3C23-4F16-B603-562A5F7E3A0C}"/>
               </a:ext>
             </a:extLst>
           </p:cNvPr>
@@ -4407,7 +4407,7 @@
           <p:cNvPr id="41" name="">
             <a:extLst xmlns:a="http://schemas.openxmlformats.org/drawingml/2006/main">
               <a:ext uri="{FF2B5EF4-FFF2-40B4-BE49-F238E27FC236}">
-                <a16:creationId xmlns:a16="http://schemas.microsoft.com/office/drawing/2014/main" id="{E57DE8E6-9610-441E-8FE4-1AB657746C79}"/>
+                <a16:creationId xmlns:a16="http://schemas.microsoft.com/office/drawing/2014/main" id="{0595F861-98E7-4D33-925B-CAEB305AE288}"/>
               </a:ext>
             </a:extLst>
           </p:cNvPr>
@@ -4469,7 +4469,7 @@
     </p:spTree>
     <p:extLst>
       <p:ext uri="{BB962C8B-B14F-4D97-AF65-F5344CB8AC3E}">
-        <p14:creationId xmlns:p14="http://schemas.microsoft.com/office/powerpoint/2010/main" val="266029297"/>
+        <p14:creationId xmlns:p14="http://schemas.microsoft.com/office/powerpoint/2010/main" val="501718621"/>
       </p:ext>
     </p:extLst>
   </p:cSld>
@@ -4493,7 +4493,7 @@
           <p:cNvPr id="1" name="">
             <a:extLst xmlns:a="http://schemas.openxmlformats.org/drawingml/2006/main">
               <a:ext uri="{FF2B5EF4-FFF2-40B4-BE49-F238E27FC236}">
-                <a16:creationId xmlns:a16="http://schemas.microsoft.com/office/drawing/2014/main" id="{AE31F4EC-9FC2-4CE1-BD9D-21F747C26230}"/>
+                <a16:creationId xmlns:a16="http://schemas.microsoft.com/office/drawing/2014/main" id="{88C9CA51-705E-4597-83F4-1682C0E41A39}"/>
               </a:ext>
             </a:extLst>
           </p:cNvPr>
@@ -4528,7 +4528,7 @@
           <p:cNvPr id="2" name="">
             <a:extLst xmlns:a="http://schemas.openxmlformats.org/drawingml/2006/main">
               <a:ext uri="{FF2B5EF4-FFF2-40B4-BE49-F238E27FC236}">
-                <a16:creationId xmlns:a16="http://schemas.microsoft.com/office/drawing/2014/main" id="{1EB94195-8B4E-4893-A85E-3A450A72A69F}"/>
+                <a16:creationId xmlns:a16="http://schemas.microsoft.com/office/drawing/2014/main" id="{A61DFE16-AB1F-4D9E-803C-38BC3982BFEC}"/>
               </a:ext>
             </a:extLst>
           </p:cNvPr>
@@ -4563,7 +4563,7 @@
           <p:cNvPr id="3" name="">
             <a:extLst xmlns:a="http://schemas.openxmlformats.org/drawingml/2006/main">
               <a:ext uri="{FF2B5EF4-FFF2-40B4-BE49-F238E27FC236}">
-                <a16:creationId xmlns:a16="http://schemas.microsoft.com/office/drawing/2014/main" id="{4256F071-31A4-4382-BD7F-FE59BDB483CC}"/>
+                <a16:creationId xmlns:a16="http://schemas.microsoft.com/office/drawing/2014/main" id="{536962C7-6AEC-4CF8-9443-ADA7D7F01D8D}"/>
               </a:ext>
             </a:extLst>
           </p:cNvPr>
@@ -4598,7 +4598,7 @@
           <p:cNvPr id="4" name="">
             <a:extLst xmlns:a="http://schemas.openxmlformats.org/drawingml/2006/main">
               <a:ext uri="{FF2B5EF4-FFF2-40B4-BE49-F238E27FC236}">
-                <a16:creationId xmlns:a16="http://schemas.microsoft.com/office/drawing/2014/main" id="{DE159D72-423D-460B-8028-A4EB78934061}"/>
+                <a16:creationId xmlns:a16="http://schemas.microsoft.com/office/drawing/2014/main" id="{F990280D-9860-4D88-9FA6-7AAEE03C5A95}"/>
               </a:ext>
             </a:extLst>
           </p:cNvPr>
@@ -4662,7 +4662,7 @@
           <p:cNvPr id="5" name="">
             <a:extLst xmlns:a="http://schemas.openxmlformats.org/drawingml/2006/main">
               <a:ext uri="{FF2B5EF4-FFF2-40B4-BE49-F238E27FC236}">
-                <a16:creationId xmlns:a16="http://schemas.microsoft.com/office/drawing/2014/main" id="{70769234-5C1C-48A4-88A3-C6E38CE509EF}"/>
+                <a16:creationId xmlns:a16="http://schemas.microsoft.com/office/drawing/2014/main" id="{93714961-E331-49F8-9C31-7A983084F16B}"/>
               </a:ext>
             </a:extLst>
           </p:cNvPr>
@@ -4726,7 +4726,7 @@
           <p:cNvPr id="6" name="">
             <a:extLst xmlns:a="http://schemas.openxmlformats.org/drawingml/2006/main">
               <a:ext uri="{FF2B5EF4-FFF2-40B4-BE49-F238E27FC236}">
-                <a16:creationId xmlns:a16="http://schemas.microsoft.com/office/drawing/2014/main" id="{1978E1D6-BFD6-4824-BB83-ABD9B01C5FDC}"/>
+                <a16:creationId xmlns:a16="http://schemas.microsoft.com/office/drawing/2014/main" id="{4B736947-4E89-4C94-A650-D8BE0D3AB00E}"/>
               </a:ext>
             </a:extLst>
           </p:cNvPr>
@@ -4790,7 +4790,7 @@
           <p:cNvPr id="7" name="">
             <a:extLst xmlns:a="http://schemas.openxmlformats.org/drawingml/2006/main">
               <a:ext uri="{FF2B5EF4-FFF2-40B4-BE49-F238E27FC236}">
-                <a16:creationId xmlns:a16="http://schemas.microsoft.com/office/drawing/2014/main" id="{5BC92A0F-E4E1-4727-866E-FD09BB38C70E}"/>
+                <a16:creationId xmlns:a16="http://schemas.microsoft.com/office/drawing/2014/main" id="{EEDF6D39-E4F9-47DB-B032-B302DFF80220}"/>
               </a:ext>
             </a:extLst>
           </p:cNvPr>
@@ -4854,7 +4854,7 @@
           <p:cNvPr id="8" name="">
             <a:extLst xmlns:a="http://schemas.openxmlformats.org/drawingml/2006/main">
               <a:ext uri="{FF2B5EF4-FFF2-40B4-BE49-F238E27FC236}">
-                <a16:creationId xmlns:a16="http://schemas.microsoft.com/office/drawing/2014/main" id="{4E6FDDD7-4BF8-4455-B822-01A449E5A2B0}"/>
+                <a16:creationId xmlns:a16="http://schemas.microsoft.com/office/drawing/2014/main" id="{17F06D4D-C78B-4BAC-9D35-E22A30DD21E5}"/>
               </a:ext>
             </a:extLst>
           </p:cNvPr>
@@ -4918,7 +4918,7 @@
           <p:cNvPr id="9" name="">
             <a:extLst xmlns:a="http://schemas.openxmlformats.org/drawingml/2006/main">
               <a:ext uri="{FF2B5EF4-FFF2-40B4-BE49-F238E27FC236}">
-                <a16:creationId xmlns:a16="http://schemas.microsoft.com/office/drawing/2014/main" id="{1339CDB3-FD40-4700-8C91-3D15219F66AE}"/>
+                <a16:creationId xmlns:a16="http://schemas.microsoft.com/office/drawing/2014/main" id="{EBB51BD9-15BC-4822-833C-69BAE60D4BEF}"/>
               </a:ext>
             </a:extLst>
           </p:cNvPr>
@@ -4982,7 +4982,7 @@
           <p:cNvPr id="10" name="">
             <a:extLst xmlns:a="http://schemas.openxmlformats.org/drawingml/2006/main">
               <a:ext uri="{FF2B5EF4-FFF2-40B4-BE49-F238E27FC236}">
-                <a16:creationId xmlns:a16="http://schemas.microsoft.com/office/drawing/2014/main" id="{F543F15F-4BE2-44A8-AF77-7B9BC0DF9D18}"/>
+                <a16:creationId xmlns:a16="http://schemas.microsoft.com/office/drawing/2014/main" id="{A77479C9-D707-4C78-B655-7B13C07CDAB7}"/>
               </a:ext>
             </a:extLst>
           </p:cNvPr>
@@ -5015,7 +5015,7 @@
           <p:cNvPr id="11" name="">
             <a:extLst xmlns:a="http://schemas.openxmlformats.org/drawingml/2006/main">
               <a:ext uri="{FF2B5EF4-FFF2-40B4-BE49-F238E27FC236}">
-                <a16:creationId xmlns:a16="http://schemas.microsoft.com/office/drawing/2014/main" id="{85783305-7A4E-4794-89FB-91DBC6BC9955}"/>
+                <a16:creationId xmlns:a16="http://schemas.microsoft.com/office/drawing/2014/main" id="{FF21429D-36EE-4851-BF6A-7554116F1EC4}"/>
               </a:ext>
             </a:extLst>
           </p:cNvPr>
@@ -5079,7 +5079,7 @@
           <p:cNvPr id="12" name="">
             <a:extLst xmlns:a="http://schemas.openxmlformats.org/drawingml/2006/main">
               <a:ext uri="{FF2B5EF4-FFF2-40B4-BE49-F238E27FC236}">
-                <a16:creationId xmlns:a16="http://schemas.microsoft.com/office/drawing/2014/main" id="{5506456D-5C75-4C69-97DE-0A378082E2EC}"/>
+                <a16:creationId xmlns:a16="http://schemas.microsoft.com/office/drawing/2014/main" id="{937FD39B-CAFC-49A0-BB09-5625033FDCB3}"/>
               </a:ext>
             </a:extLst>
           </p:cNvPr>
@@ -5112,7 +5112,7 @@
           <p:cNvPr id="13" name="">
             <a:extLst xmlns:a="http://schemas.openxmlformats.org/drawingml/2006/main">
               <a:ext uri="{FF2B5EF4-FFF2-40B4-BE49-F238E27FC236}">
-                <a16:creationId xmlns:a16="http://schemas.microsoft.com/office/drawing/2014/main" id="{3DA8108F-0577-4D48-923E-1CF36D2E2CE8}"/>
+                <a16:creationId xmlns:a16="http://schemas.microsoft.com/office/drawing/2014/main" id="{7E87041F-6A13-495E-974A-C49EC6DD605E}"/>
               </a:ext>
             </a:extLst>
           </p:cNvPr>
@@ -5176,7 +5176,7 @@
           <p:cNvPr id="14" name="">
             <a:extLst xmlns:a="http://schemas.openxmlformats.org/drawingml/2006/main">
               <a:ext uri="{FF2B5EF4-FFF2-40B4-BE49-F238E27FC236}">
-                <a16:creationId xmlns:a16="http://schemas.microsoft.com/office/drawing/2014/main" id="{1198B876-C718-4031-A5A4-B474689F96C2}"/>
+                <a16:creationId xmlns:a16="http://schemas.microsoft.com/office/drawing/2014/main" id="{10EC29CE-880F-4DD2-865F-69A7D7375380}"/>
               </a:ext>
             </a:extLst>
           </p:cNvPr>
@@ -5209,7 +5209,7 @@
           <p:cNvPr id="15" name="">
             <a:extLst xmlns:a="http://schemas.openxmlformats.org/drawingml/2006/main">
               <a:ext uri="{FF2B5EF4-FFF2-40B4-BE49-F238E27FC236}">
-                <a16:creationId xmlns:a16="http://schemas.microsoft.com/office/drawing/2014/main" id="{C4EAA38A-9D54-49FC-8A1A-2D804960293F}"/>
+                <a16:creationId xmlns:a16="http://schemas.microsoft.com/office/drawing/2014/main" id="{86900527-6EE1-4151-8F69-CE22A9403052}"/>
               </a:ext>
             </a:extLst>
           </p:cNvPr>
@@ -5273,7 +5273,7 @@
           <p:cNvPr id="16" name="">
             <a:extLst xmlns:a="http://schemas.openxmlformats.org/drawingml/2006/main">
               <a:ext uri="{FF2B5EF4-FFF2-40B4-BE49-F238E27FC236}">
-                <a16:creationId xmlns:a16="http://schemas.microsoft.com/office/drawing/2014/main" id="{73A59285-568D-433C-8B14-2AAF6A538FEA}"/>
+                <a16:creationId xmlns:a16="http://schemas.microsoft.com/office/drawing/2014/main" id="{48A6BEFB-2B67-40EA-8E7D-7A90887FC3A5}"/>
               </a:ext>
             </a:extLst>
           </p:cNvPr>
@@ -5306,7 +5306,7 @@
           <p:cNvPr id="17" name="">
             <a:extLst xmlns:a="http://schemas.openxmlformats.org/drawingml/2006/main">
               <a:ext uri="{FF2B5EF4-FFF2-40B4-BE49-F238E27FC236}">
-                <a16:creationId xmlns:a16="http://schemas.microsoft.com/office/drawing/2014/main" id="{9B249C4D-8EFB-484E-8B61-62F7248D4D4D}"/>
+                <a16:creationId xmlns:a16="http://schemas.microsoft.com/office/drawing/2014/main" id="{624D35CD-7C4F-4175-9A25-D416246E6321}"/>
               </a:ext>
             </a:extLst>
           </p:cNvPr>
@@ -5370,7 +5370,7 @@
           <p:cNvPr id="18" name="">
             <a:extLst xmlns:a="http://schemas.openxmlformats.org/drawingml/2006/main">
               <a:ext uri="{FF2B5EF4-FFF2-40B4-BE49-F238E27FC236}">
-                <a16:creationId xmlns:a16="http://schemas.microsoft.com/office/drawing/2014/main" id="{F72DC1A9-772F-45D0-AB54-99DAB70C5C01}"/>
+                <a16:creationId xmlns:a16="http://schemas.microsoft.com/office/drawing/2014/main" id="{79EAFE38-CD2F-4999-BB76-C965239B36F6}"/>
               </a:ext>
             </a:extLst>
           </p:cNvPr>
@@ -5403,7 +5403,7 @@
           <p:cNvPr id="19" name="">
             <a:extLst xmlns:a="http://schemas.openxmlformats.org/drawingml/2006/main">
               <a:ext uri="{FF2B5EF4-FFF2-40B4-BE49-F238E27FC236}">
-                <a16:creationId xmlns:a16="http://schemas.microsoft.com/office/drawing/2014/main" id="{B7F434C9-2A97-4A0E-9F25-A6AD6EDBC186}"/>
+                <a16:creationId xmlns:a16="http://schemas.microsoft.com/office/drawing/2014/main" id="{9A2D1D92-21F3-4AEE-9263-AC38D926DBD7}"/>
               </a:ext>
             </a:extLst>
           </p:cNvPr>
@@ -5467,7 +5467,7 @@
           <p:cNvPr id="20" name="">
             <a:extLst xmlns:a="http://schemas.openxmlformats.org/drawingml/2006/main">
               <a:ext uri="{FF2B5EF4-FFF2-40B4-BE49-F238E27FC236}">
-                <a16:creationId xmlns:a16="http://schemas.microsoft.com/office/drawing/2014/main" id="{C6DE2413-702B-45BF-943C-B0ABE03A625F}"/>
+                <a16:creationId xmlns:a16="http://schemas.microsoft.com/office/drawing/2014/main" id="{DA00EF5C-5658-4AE8-9209-BC0742EB909D}"/>
               </a:ext>
             </a:extLst>
           </p:cNvPr>
@@ -5500,7 +5500,7 @@
           <p:cNvPr id="21" name="">
             <a:extLst xmlns:a="http://schemas.openxmlformats.org/drawingml/2006/main">
               <a:ext uri="{FF2B5EF4-FFF2-40B4-BE49-F238E27FC236}">
-                <a16:creationId xmlns:a16="http://schemas.microsoft.com/office/drawing/2014/main" id="{03C02043-43BE-4F1B-AC91-B4382AD65607}"/>
+                <a16:creationId xmlns:a16="http://schemas.microsoft.com/office/drawing/2014/main" id="{FD242C52-B0FE-4B36-AD64-4EB8EA8371AA}"/>
               </a:ext>
             </a:extLst>
           </p:cNvPr>
@@ -5564,7 +5564,7 @@
           <p:cNvPr id="22" name="">
             <a:extLst xmlns:a="http://schemas.openxmlformats.org/drawingml/2006/main">
               <a:ext uri="{FF2B5EF4-FFF2-40B4-BE49-F238E27FC236}">
-                <a16:creationId xmlns:a16="http://schemas.microsoft.com/office/drawing/2014/main" id="{CC77E16C-53AC-4E1A-944F-368E6B4526CA}"/>
+                <a16:creationId xmlns:a16="http://schemas.microsoft.com/office/drawing/2014/main" id="{7C3201B6-F19F-492E-8CBE-61AE4831401B}"/>
               </a:ext>
             </a:extLst>
           </p:cNvPr>
@@ -5597,7 +5597,7 @@
           <p:cNvPr id="23" name="">
             <a:extLst xmlns:a="http://schemas.openxmlformats.org/drawingml/2006/main">
               <a:ext uri="{FF2B5EF4-FFF2-40B4-BE49-F238E27FC236}">
-                <a16:creationId xmlns:a16="http://schemas.microsoft.com/office/drawing/2014/main" id="{2B75CBE7-3560-4B5B-B0C9-DB723BBC134D}"/>
+                <a16:creationId xmlns:a16="http://schemas.microsoft.com/office/drawing/2014/main" id="{D6D6C223-2124-4C2E-BB8E-29FD1A6DF7CF}"/>
               </a:ext>
             </a:extLst>
           </p:cNvPr>
@@ -5661,7 +5661,7 @@
           <p:cNvPr id="24" name="">
             <a:extLst xmlns:a="http://schemas.openxmlformats.org/drawingml/2006/main">
               <a:ext uri="{FF2B5EF4-FFF2-40B4-BE49-F238E27FC236}">
-                <a16:creationId xmlns:a16="http://schemas.microsoft.com/office/drawing/2014/main" id="{6BBCFDDE-0CA2-4918-9A90-8E05ACD6DE97}"/>
+                <a16:creationId xmlns:a16="http://schemas.microsoft.com/office/drawing/2014/main" id="{4B59ED1F-D208-4DF1-AD73-39DF81BD203D}"/>
               </a:ext>
             </a:extLst>
           </p:cNvPr>
@@ -5694,7 +5694,7 @@
           <p:cNvPr id="25" name="">
             <a:extLst xmlns:a="http://schemas.openxmlformats.org/drawingml/2006/main">
               <a:ext uri="{FF2B5EF4-FFF2-40B4-BE49-F238E27FC236}">
-                <a16:creationId xmlns:a16="http://schemas.microsoft.com/office/drawing/2014/main" id="{6E6484B4-BA7A-45A7-B442-70165A0824E1}"/>
+                <a16:creationId xmlns:a16="http://schemas.microsoft.com/office/drawing/2014/main" id="{287EFEC8-DEFC-4DCA-95E6-82467EACA9A3}"/>
               </a:ext>
             </a:extLst>
           </p:cNvPr>
@@ -5758,7 +5758,7 @@
           <p:cNvPr id="26" name="">
             <a:extLst xmlns:a="http://schemas.openxmlformats.org/drawingml/2006/main">
               <a:ext uri="{FF2B5EF4-FFF2-40B4-BE49-F238E27FC236}">
-                <a16:creationId xmlns:a16="http://schemas.microsoft.com/office/drawing/2014/main" id="{6B1F0031-F93C-4757-81D1-52FCE5171E7C}"/>
+                <a16:creationId xmlns:a16="http://schemas.microsoft.com/office/drawing/2014/main" id="{37ACA109-CDCA-4292-800B-3AD4FED95662}"/>
               </a:ext>
             </a:extLst>
           </p:cNvPr>
@@ -5791,7 +5791,7 @@
           <p:cNvPr id="27" name="">
             <a:extLst xmlns:a="http://schemas.openxmlformats.org/drawingml/2006/main">
               <a:ext uri="{FF2B5EF4-FFF2-40B4-BE49-F238E27FC236}">
-                <a16:creationId xmlns:a16="http://schemas.microsoft.com/office/drawing/2014/main" id="{DFD01F35-C349-4E84-A950-19FA732BBF88}"/>
+                <a16:creationId xmlns:a16="http://schemas.microsoft.com/office/drawing/2014/main" id="{642C9C97-8170-4A42-B7B1-7A2662235E24}"/>
               </a:ext>
             </a:extLst>
           </p:cNvPr>
@@ -5855,7 +5855,7 @@
           <p:cNvPr id="28" name="">
             <a:extLst xmlns:a="http://schemas.openxmlformats.org/drawingml/2006/main">
               <a:ext uri="{FF2B5EF4-FFF2-40B4-BE49-F238E27FC236}">
-                <a16:creationId xmlns:a16="http://schemas.microsoft.com/office/drawing/2014/main" id="{667C46E3-9801-431E-965B-D41D0A0F8DEA}"/>
+                <a16:creationId xmlns:a16="http://schemas.microsoft.com/office/drawing/2014/main" id="{7F58C991-EC53-48C1-8BB7-A4766D457126}"/>
               </a:ext>
             </a:extLst>
           </p:cNvPr>
@@ -5888,7 +5888,7 @@
           <p:cNvPr id="29" name="">
             <a:extLst xmlns:a="http://schemas.openxmlformats.org/drawingml/2006/main">
               <a:ext uri="{FF2B5EF4-FFF2-40B4-BE49-F238E27FC236}">
-                <a16:creationId xmlns:a16="http://schemas.microsoft.com/office/drawing/2014/main" id="{47A4E054-56D6-4FC5-8DB4-6E0A61F430E4}"/>
+                <a16:creationId xmlns:a16="http://schemas.microsoft.com/office/drawing/2014/main" id="{664B9454-6D86-4BA3-88FE-6D2E58C7CE20}"/>
               </a:ext>
             </a:extLst>
           </p:cNvPr>
@@ -5952,7 +5952,7 @@
           <p:cNvPr id="30" name="">
             <a:extLst xmlns:a="http://schemas.openxmlformats.org/drawingml/2006/main">
               <a:ext uri="{FF2B5EF4-FFF2-40B4-BE49-F238E27FC236}">
-                <a16:creationId xmlns:a16="http://schemas.microsoft.com/office/drawing/2014/main" id="{5A38326E-4F32-4D66-AB8E-FF8AAAAFB2A6}"/>
+                <a16:creationId xmlns:a16="http://schemas.microsoft.com/office/drawing/2014/main" id="{9999343A-6645-4587-A37B-05AD3CD96257}"/>
               </a:ext>
             </a:extLst>
           </p:cNvPr>
@@ -5985,7 +5985,7 @@
           <p:cNvPr id="31" name="">
             <a:extLst xmlns:a="http://schemas.openxmlformats.org/drawingml/2006/main">
               <a:ext uri="{FF2B5EF4-FFF2-40B4-BE49-F238E27FC236}">
-                <a16:creationId xmlns:a16="http://schemas.microsoft.com/office/drawing/2014/main" id="{33499CB0-17B6-4799-B39F-75292A780FE2}"/>
+                <a16:creationId xmlns:a16="http://schemas.microsoft.com/office/drawing/2014/main" id="{8DB590CE-8A4D-4152-93C4-0551E6676EB1}"/>
               </a:ext>
             </a:extLst>
           </p:cNvPr>
@@ -6049,7 +6049,7 @@
           <p:cNvPr id="32" name="">
             <a:extLst xmlns:a="http://schemas.openxmlformats.org/drawingml/2006/main">
               <a:ext uri="{FF2B5EF4-FFF2-40B4-BE49-F238E27FC236}">
-                <a16:creationId xmlns:a16="http://schemas.microsoft.com/office/drawing/2014/main" id="{F9F5EFB1-FB61-47EB-9CC5-E9319D2CB296}"/>
+                <a16:creationId xmlns:a16="http://schemas.microsoft.com/office/drawing/2014/main" id="{99981F8F-F909-4CC3-A32D-C15E87282490}"/>
               </a:ext>
             </a:extLst>
           </p:cNvPr>
@@ -6082,7 +6082,7 @@
           <p:cNvPr id="33" name="">
             <a:extLst xmlns:a="http://schemas.openxmlformats.org/drawingml/2006/main">
               <a:ext uri="{FF2B5EF4-FFF2-40B4-BE49-F238E27FC236}">
-                <a16:creationId xmlns:a16="http://schemas.microsoft.com/office/drawing/2014/main" id="{C1FC3D52-708D-4E1D-BDA6-E31466937C22}"/>
+                <a16:creationId xmlns:a16="http://schemas.microsoft.com/office/drawing/2014/main" id="{390213ED-9BD8-4A53-9F72-2693A00E3601}"/>
               </a:ext>
             </a:extLst>
           </p:cNvPr>
@@ -6146,7 +6146,7 @@
           <p:cNvPr id="34" name="">
             <a:extLst xmlns:a="http://schemas.openxmlformats.org/drawingml/2006/main">
               <a:ext uri="{FF2B5EF4-FFF2-40B4-BE49-F238E27FC236}">
-                <a16:creationId xmlns:a16="http://schemas.microsoft.com/office/drawing/2014/main" id="{DDAB1618-BC10-470F-BFD1-FB0B930E7E81}"/>
+                <a16:creationId xmlns:a16="http://schemas.microsoft.com/office/drawing/2014/main" id="{A26A1B65-06A3-4BD4-9B6F-FBAC20E05F12}"/>
               </a:ext>
             </a:extLst>
           </p:cNvPr>
@@ -6181,7 +6181,7 @@
           <p:cNvPr id="35" name="">
             <a:extLst xmlns:a="http://schemas.openxmlformats.org/drawingml/2006/main">
               <a:ext uri="{FF2B5EF4-FFF2-40B4-BE49-F238E27FC236}">
-                <a16:creationId xmlns:a16="http://schemas.microsoft.com/office/drawing/2014/main" id="{FD514281-69D3-409D-A3BC-D1936DB075EA}"/>
+                <a16:creationId xmlns:a16="http://schemas.microsoft.com/office/drawing/2014/main" id="{8676171F-DFAD-4EE1-9027-9BCCA13DAAA7}"/>
               </a:ext>
             </a:extLst>
           </p:cNvPr>
@@ -6216,7 +6216,7 @@
           <p:cNvPr id="36" name="">
             <a:extLst xmlns:a="http://schemas.openxmlformats.org/drawingml/2006/main">
               <a:ext uri="{FF2B5EF4-FFF2-40B4-BE49-F238E27FC236}">
-                <a16:creationId xmlns:a16="http://schemas.microsoft.com/office/drawing/2014/main" id="{1E90BBE0-BEC3-464A-8C7C-D255D97B66B9}"/>
+                <a16:creationId xmlns:a16="http://schemas.microsoft.com/office/drawing/2014/main" id="{054E7A8A-BB79-430C-9565-356F6AD4A2E1}"/>
               </a:ext>
             </a:extLst>
           </p:cNvPr>
@@ -6280,7 +6280,7 @@
           <p:cNvPr id="37" name="">
             <a:extLst xmlns:a="http://schemas.openxmlformats.org/drawingml/2006/main">
               <a:ext uri="{FF2B5EF4-FFF2-40B4-BE49-F238E27FC236}">
-                <a16:creationId xmlns:a16="http://schemas.microsoft.com/office/drawing/2014/main" id="{345C26A8-354F-4B9C-9B06-4059DE4C7C78}"/>
+                <a16:creationId xmlns:a16="http://schemas.microsoft.com/office/drawing/2014/main" id="{BA830BB9-7BE4-42DB-97B5-98ACEC5D9536}"/>
               </a:ext>
             </a:extLst>
           </p:cNvPr>
@@ -6342,7 +6342,7 @@
     </p:spTree>
     <p:extLst>
       <p:ext uri="{BB962C8B-B14F-4D97-AF65-F5344CB8AC3E}">
-        <p14:creationId xmlns:p14="http://schemas.microsoft.com/office/powerpoint/2010/main" val="1841319431"/>
+        <p14:creationId xmlns:p14="http://schemas.microsoft.com/office/powerpoint/2010/main" val="1360315201"/>
       </p:ext>
     </p:extLst>
   </p:cSld>
@@ -6366,7 +6366,7 @@
           <p:cNvPr id="1" name="">
             <a:extLst xmlns:a="http://schemas.openxmlformats.org/drawingml/2006/main">
               <a:ext uri="{FF2B5EF4-FFF2-40B4-BE49-F238E27FC236}">
-                <a16:creationId xmlns:a16="http://schemas.microsoft.com/office/drawing/2014/main" id="{46C7CA93-716A-4195-8E23-F2C3D075EAB5}"/>
+                <a16:creationId xmlns:a16="http://schemas.microsoft.com/office/drawing/2014/main" id="{397B9C04-294E-4D69-B509-A4EDFB748898}"/>
               </a:ext>
             </a:extLst>
           </p:cNvPr>
@@ -6401,7 +6401,7 @@
           <p:cNvPr id="2" name="">
             <a:extLst xmlns:a="http://schemas.openxmlformats.org/drawingml/2006/main">
               <a:ext uri="{FF2B5EF4-FFF2-40B4-BE49-F238E27FC236}">
-                <a16:creationId xmlns:a16="http://schemas.microsoft.com/office/drawing/2014/main" id="{E9D8994C-8C5F-48BB-8E5F-AB345AFF3797}"/>
+                <a16:creationId xmlns:a16="http://schemas.microsoft.com/office/drawing/2014/main" id="{790DF341-F24C-4124-AEA1-08131992E7D8}"/>
               </a:ext>
             </a:extLst>
           </p:cNvPr>
@@ -6436,7 +6436,7 @@
           <p:cNvPr id="3" name="">
             <a:extLst xmlns:a="http://schemas.openxmlformats.org/drawingml/2006/main">
               <a:ext uri="{FF2B5EF4-FFF2-40B4-BE49-F238E27FC236}">
-                <a16:creationId xmlns:a16="http://schemas.microsoft.com/office/drawing/2014/main" id="{4BA07BAF-F36C-4670-ABA9-641C5A5BD7F7}"/>
+                <a16:creationId xmlns:a16="http://schemas.microsoft.com/office/drawing/2014/main" id="{64007153-CE6D-42E2-98A6-43A28277370A}"/>
               </a:ext>
             </a:extLst>
           </p:cNvPr>
@@ -6471,7 +6471,7 @@
           <p:cNvPr id="4" name="">
             <a:extLst xmlns:a="http://schemas.openxmlformats.org/drawingml/2006/main">
               <a:ext uri="{FF2B5EF4-FFF2-40B4-BE49-F238E27FC236}">
-                <a16:creationId xmlns:a16="http://schemas.microsoft.com/office/drawing/2014/main" id="{FFA26859-2C1C-4BF0-A395-8D168C25AE00}"/>
+                <a16:creationId xmlns:a16="http://schemas.microsoft.com/office/drawing/2014/main" id="{5ACB63B4-64E7-422D-949F-2C1C51B47194}"/>
               </a:ext>
             </a:extLst>
           </p:cNvPr>
@@ -6535,7 +6535,7 @@
           <p:cNvPr id="5" name="">
             <a:extLst xmlns:a="http://schemas.openxmlformats.org/drawingml/2006/main">
               <a:ext uri="{FF2B5EF4-FFF2-40B4-BE49-F238E27FC236}">
-                <a16:creationId xmlns:a16="http://schemas.microsoft.com/office/drawing/2014/main" id="{401C5961-ABDE-4C29-B98B-2DFDCFE7612E}"/>
+                <a16:creationId xmlns:a16="http://schemas.microsoft.com/office/drawing/2014/main" id="{EE3D9285-CB97-49B4-AF97-2E58AABEAFEC}"/>
               </a:ext>
             </a:extLst>
           </p:cNvPr>
@@ -6599,7 +6599,7 @@
           <p:cNvPr id="6" name="">
             <a:extLst xmlns:a="http://schemas.openxmlformats.org/drawingml/2006/main">
               <a:ext uri="{FF2B5EF4-FFF2-40B4-BE49-F238E27FC236}">
-                <a16:creationId xmlns:a16="http://schemas.microsoft.com/office/drawing/2014/main" id="{FD9109C7-83B8-459E-A5F1-8134D5491B36}"/>
+                <a16:creationId xmlns:a16="http://schemas.microsoft.com/office/drawing/2014/main" id="{44A5FA33-04B1-4D03-B551-897086609801}"/>
               </a:ext>
             </a:extLst>
           </p:cNvPr>
@@ -6663,7 +6663,7 @@
           <p:cNvPr id="7" name="">
             <a:extLst xmlns:a="http://schemas.openxmlformats.org/drawingml/2006/main">
               <a:ext uri="{FF2B5EF4-FFF2-40B4-BE49-F238E27FC236}">
-                <a16:creationId xmlns:a16="http://schemas.microsoft.com/office/drawing/2014/main" id="{1CC8E641-5170-4DCC-98EA-EED6DE67BDAE}"/>
+                <a16:creationId xmlns:a16="http://schemas.microsoft.com/office/drawing/2014/main" id="{F77BBADC-43BF-446A-BCA0-A2717F9C8938}"/>
               </a:ext>
             </a:extLst>
           </p:cNvPr>
@@ -6727,7 +6727,7 @@
           <p:cNvPr id="8" name="">
             <a:extLst xmlns:a="http://schemas.openxmlformats.org/drawingml/2006/main">
               <a:ext uri="{FF2B5EF4-FFF2-40B4-BE49-F238E27FC236}">
-                <a16:creationId xmlns:a16="http://schemas.microsoft.com/office/drawing/2014/main" id="{FE42B648-444C-467D-BC6E-92E9D61A2ACB}"/>
+                <a16:creationId xmlns:a16="http://schemas.microsoft.com/office/drawing/2014/main" id="{8DE41479-52D2-4710-ACA7-9BD476DB3AC2}"/>
               </a:ext>
             </a:extLst>
           </p:cNvPr>
@@ -6791,7 +6791,7 @@
           <p:cNvPr id="9" name="">
             <a:extLst xmlns:a="http://schemas.openxmlformats.org/drawingml/2006/main">
               <a:ext uri="{FF2B5EF4-FFF2-40B4-BE49-F238E27FC236}">
-                <a16:creationId xmlns:a16="http://schemas.microsoft.com/office/drawing/2014/main" id="{7E09E963-EA99-4B3E-92DD-5DB9138BC144}"/>
+                <a16:creationId xmlns:a16="http://schemas.microsoft.com/office/drawing/2014/main" id="{6E5ECD89-817C-464E-80D7-9A691B5D7A8A}"/>
               </a:ext>
             </a:extLst>
           </p:cNvPr>
@@ -6855,7 +6855,7 @@
           <p:cNvPr id="10" name="">
             <a:extLst xmlns:a="http://schemas.openxmlformats.org/drawingml/2006/main">
               <a:ext uri="{FF2B5EF4-FFF2-40B4-BE49-F238E27FC236}">
-                <a16:creationId xmlns:a16="http://schemas.microsoft.com/office/drawing/2014/main" id="{F3299F44-A689-4DCD-9420-FCAE3D0C7DCC}"/>
+                <a16:creationId xmlns:a16="http://schemas.microsoft.com/office/drawing/2014/main" id="{438E3764-D627-4176-8FB2-18F01B7B5E1A}"/>
               </a:ext>
             </a:extLst>
           </p:cNvPr>
@@ -6888,7 +6888,7 @@
           <p:cNvPr id="11" name="">
             <a:extLst xmlns:a="http://schemas.openxmlformats.org/drawingml/2006/main">
               <a:ext uri="{FF2B5EF4-FFF2-40B4-BE49-F238E27FC236}">
-                <a16:creationId xmlns:a16="http://schemas.microsoft.com/office/drawing/2014/main" id="{F10F7386-F6C2-40DD-9D36-9CBB07409845}"/>
+                <a16:creationId xmlns:a16="http://schemas.microsoft.com/office/drawing/2014/main" id="{16C84B45-4913-45DD-8A53-65D126521EAB}"/>
               </a:ext>
             </a:extLst>
           </p:cNvPr>
@@ -6923,7 +6923,7 @@
           <p:cNvPr id="12" name="">
             <a:extLst xmlns:a="http://schemas.openxmlformats.org/drawingml/2006/main">
               <a:ext uri="{FF2B5EF4-FFF2-40B4-BE49-F238E27FC236}">
-                <a16:creationId xmlns:a16="http://schemas.microsoft.com/office/drawing/2014/main" id="{0EEF5D95-C4E8-4B51-B22B-1745D9B82FD2}"/>
+                <a16:creationId xmlns:a16="http://schemas.microsoft.com/office/drawing/2014/main" id="{5341D1B4-3D5D-4D18-8F02-059AC8335D94}"/>
               </a:ext>
             </a:extLst>
           </p:cNvPr>
@@ -6987,7 +6987,7 @@
           <p:cNvPr id="13" name="">
             <a:extLst xmlns:a="http://schemas.openxmlformats.org/drawingml/2006/main">
               <a:ext uri="{FF2B5EF4-FFF2-40B4-BE49-F238E27FC236}">
-                <a16:creationId xmlns:a16="http://schemas.microsoft.com/office/drawing/2014/main" id="{C06FA1C8-349C-4CB3-BE81-7DD43D5D7445}"/>
+                <a16:creationId xmlns:a16="http://schemas.microsoft.com/office/drawing/2014/main" id="{329E3F80-4F14-408A-B683-1810533D5488}"/>
               </a:ext>
             </a:extLst>
           </p:cNvPr>
@@ -7022,7 +7022,7 @@
           <p:cNvPr id="14" name="">
             <a:extLst xmlns:a="http://schemas.openxmlformats.org/drawingml/2006/main">
               <a:ext uri="{FF2B5EF4-FFF2-40B4-BE49-F238E27FC236}">
-                <a16:creationId xmlns:a16="http://schemas.microsoft.com/office/drawing/2014/main" id="{91B12A33-1A08-4B71-BC0D-E8F62EBCECB1}"/>
+                <a16:creationId xmlns:a16="http://schemas.microsoft.com/office/drawing/2014/main" id="{2AD0A6BE-DF42-4A0C-8742-C4F9C587CB95}"/>
               </a:ext>
             </a:extLst>
           </p:cNvPr>
@@ -7086,7 +7086,7 @@
           <p:cNvPr id="15" name="">
             <a:extLst xmlns:a="http://schemas.openxmlformats.org/drawingml/2006/main">
               <a:ext uri="{FF2B5EF4-FFF2-40B4-BE49-F238E27FC236}">
-                <a16:creationId xmlns:a16="http://schemas.microsoft.com/office/drawing/2014/main" id="{7D04E7FB-30B0-4579-95D9-FCA2AC2DDC0E}"/>
+                <a16:creationId xmlns:a16="http://schemas.microsoft.com/office/drawing/2014/main" id="{17601816-394F-439A-9B49-6C295C2B16E3}"/>
               </a:ext>
             </a:extLst>
           </p:cNvPr>
@@ -7121,7 +7121,7 @@
           <p:cNvPr id="16" name="">
             <a:extLst xmlns:a="http://schemas.openxmlformats.org/drawingml/2006/main">
               <a:ext uri="{FF2B5EF4-FFF2-40B4-BE49-F238E27FC236}">
-                <a16:creationId xmlns:a16="http://schemas.microsoft.com/office/drawing/2014/main" id="{E14E227D-1C6C-4260-926F-A7A3C574FF40}"/>
+                <a16:creationId xmlns:a16="http://schemas.microsoft.com/office/drawing/2014/main" id="{F96ED860-C5CC-4145-A6EC-5B3D142D5EE7}"/>
               </a:ext>
             </a:extLst>
           </p:cNvPr>
@@ -7175,7 +7175,7 @@
                 <a:ea typeface="Aptos"/>
                 <a:cs typeface="Aptos"/>
               </a:rPr>
-              <a:t>Pricing: free trial plus ₹149/month student plan.</a:t>
+              <a:t>Pricing: ₹0 trial, ₹49 pass, ₹149/month, ₹399 semester, custom campus.</a:t>
             </a:r>
           </a:p>
         </p:txBody>
@@ -7185,7 +7185,7 @@
           <p:cNvPr id="17" name="">
             <a:extLst xmlns:a="http://schemas.openxmlformats.org/drawingml/2006/main">
               <a:ext uri="{FF2B5EF4-FFF2-40B4-BE49-F238E27FC236}">
-                <a16:creationId xmlns:a16="http://schemas.microsoft.com/office/drawing/2014/main" id="{F91B16F2-51A0-4726-9ED0-1C90D24B18AA}"/>
+                <a16:creationId xmlns:a16="http://schemas.microsoft.com/office/drawing/2014/main" id="{E6422A8F-32BA-482E-9DBE-BB364A30FE33}"/>
               </a:ext>
             </a:extLst>
           </p:cNvPr>
@@ -7218,7 +7218,7 @@
           <p:cNvPr id="18" name="">
             <a:extLst xmlns:a="http://schemas.openxmlformats.org/drawingml/2006/main">
               <a:ext uri="{FF2B5EF4-FFF2-40B4-BE49-F238E27FC236}">
-                <a16:creationId xmlns:a16="http://schemas.microsoft.com/office/drawing/2014/main" id="{97D73C1B-343A-4C2F-94C3-AF6BB1950A0B}"/>
+                <a16:creationId xmlns:a16="http://schemas.microsoft.com/office/drawing/2014/main" id="{8237E2AB-ECCF-4242-8A68-2D44D4224757}"/>
               </a:ext>
             </a:extLst>
           </p:cNvPr>
@@ -7282,7 +7282,7 @@
           <p:cNvPr id="19" name="">
             <a:extLst xmlns:a="http://schemas.openxmlformats.org/drawingml/2006/main">
               <a:ext uri="{FF2B5EF4-FFF2-40B4-BE49-F238E27FC236}">
-                <a16:creationId xmlns:a16="http://schemas.microsoft.com/office/drawing/2014/main" id="{E2AAF54A-8D09-4686-804A-A9DF51BE5546}"/>
+                <a16:creationId xmlns:a16="http://schemas.microsoft.com/office/drawing/2014/main" id="{74020960-3931-4124-ACCF-3E3315B98F84}"/>
               </a:ext>
             </a:extLst>
           </p:cNvPr>
@@ -7346,7 +7346,7 @@
           <p:cNvPr id="20" name="">
             <a:extLst xmlns:a="http://schemas.openxmlformats.org/drawingml/2006/main">
               <a:ext uri="{FF2B5EF4-FFF2-40B4-BE49-F238E27FC236}">
-                <a16:creationId xmlns:a16="http://schemas.microsoft.com/office/drawing/2014/main" id="{A51137AC-B37E-416B-9EF0-A4D381B6F26D}"/>
+                <a16:creationId xmlns:a16="http://schemas.microsoft.com/office/drawing/2014/main" id="{E4F78B36-1F29-4EB3-8D01-F475FD1BB6E3}"/>
               </a:ext>
             </a:extLst>
           </p:cNvPr>
@@ -7410,7 +7410,7 @@
           <p:cNvPr id="21" name="">
             <a:extLst xmlns:a="http://schemas.openxmlformats.org/drawingml/2006/main">
               <a:ext uri="{FF2B5EF4-FFF2-40B4-BE49-F238E27FC236}">
-                <a16:creationId xmlns:a16="http://schemas.microsoft.com/office/drawing/2014/main" id="{65B46697-6335-47D1-83BC-C0EA94CDD9CC}"/>
+                <a16:creationId xmlns:a16="http://schemas.microsoft.com/office/drawing/2014/main" id="{6E2C98BB-5383-4D6B-9E85-5CB2B861AD9C}"/>
               </a:ext>
             </a:extLst>
           </p:cNvPr>
@@ -7474,7 +7474,7 @@
           <p:cNvPr id="22" name="">
             <a:extLst xmlns:a="http://schemas.openxmlformats.org/drawingml/2006/main">
               <a:ext uri="{FF2B5EF4-FFF2-40B4-BE49-F238E27FC236}">
-                <a16:creationId xmlns:a16="http://schemas.microsoft.com/office/drawing/2014/main" id="{316C33B4-D0A2-42DB-B9F6-0F213314DBB1}"/>
+                <a16:creationId xmlns:a16="http://schemas.microsoft.com/office/drawing/2014/main" id="{1B1F4A79-5FA3-455C-A244-F2DFEE425EF1}"/>
               </a:ext>
             </a:extLst>
           </p:cNvPr>
@@ -7538,7 +7538,7 @@
           <p:cNvPr id="23" name="">
             <a:extLst xmlns:a="http://schemas.openxmlformats.org/drawingml/2006/main">
               <a:ext uri="{FF2B5EF4-FFF2-40B4-BE49-F238E27FC236}">
-                <a16:creationId xmlns:a16="http://schemas.microsoft.com/office/drawing/2014/main" id="{82E2761F-0446-482F-A57A-44FEF67CCD82}"/>
+                <a16:creationId xmlns:a16="http://schemas.microsoft.com/office/drawing/2014/main" id="{AF8B3A61-71D0-416C-BDD7-BC79CB73442F}"/>
               </a:ext>
             </a:extLst>
           </p:cNvPr>
@@ -7602,7 +7602,7 @@
           <p:cNvPr id="24" name="">
             <a:extLst xmlns:a="http://schemas.openxmlformats.org/drawingml/2006/main">
               <a:ext uri="{FF2B5EF4-FFF2-40B4-BE49-F238E27FC236}">
-                <a16:creationId xmlns:a16="http://schemas.microsoft.com/office/drawing/2014/main" id="{8F967588-B2A2-408C-BD99-6D736483BFC2}"/>
+                <a16:creationId xmlns:a16="http://schemas.microsoft.com/office/drawing/2014/main" id="{44D0C31B-0E8E-4AD4-9D0D-1C591F7F4588}"/>
               </a:ext>
             </a:extLst>
           </p:cNvPr>
@@ -7666,7 +7666,7 @@
           <p:cNvPr id="25" name="">
             <a:extLst xmlns:a="http://schemas.openxmlformats.org/drawingml/2006/main">
               <a:ext uri="{FF2B5EF4-FFF2-40B4-BE49-F238E27FC236}">
-                <a16:creationId xmlns:a16="http://schemas.microsoft.com/office/drawing/2014/main" id="{69A1C237-418B-4501-9271-2E28CFEE51B2}"/>
+                <a16:creationId xmlns:a16="http://schemas.microsoft.com/office/drawing/2014/main" id="{F682AF33-8E6B-4AAA-B9E8-885C1016EFA2}"/>
               </a:ext>
             </a:extLst>
           </p:cNvPr>
@@ -7701,7 +7701,7 @@
           <p:cNvPr id="26" name="">
             <a:extLst xmlns:a="http://schemas.openxmlformats.org/drawingml/2006/main">
               <a:ext uri="{FF2B5EF4-FFF2-40B4-BE49-F238E27FC236}">
-                <a16:creationId xmlns:a16="http://schemas.microsoft.com/office/drawing/2014/main" id="{8761CC04-55BE-4B16-8A25-799E27224E82}"/>
+                <a16:creationId xmlns:a16="http://schemas.microsoft.com/office/drawing/2014/main" id="{1679644A-C1B4-45A6-BEB1-096FC6A6A1CE}"/>
               </a:ext>
             </a:extLst>
           </p:cNvPr>
@@ -7763,7 +7763,7 @@
     </p:spTree>
     <p:extLst>
       <p:ext uri="{BB962C8B-B14F-4D97-AF65-F5344CB8AC3E}">
-        <p14:creationId xmlns:p14="http://schemas.microsoft.com/office/powerpoint/2010/main" val="2041257526"/>
+        <p14:creationId xmlns:p14="http://schemas.microsoft.com/office/powerpoint/2010/main" val="2142570085"/>
       </p:ext>
     </p:extLst>
   </p:cSld>

</xml_diff>